<commit_message>
LF 10: Übung für den gleichzeitigen Einsatz in der Klasse
Name ist vor dem Start Pflicht, Aufgaben werden je Durchgang gemischt,
der Nachweis zeigt die Uhrzeit. Tipp für unentschlossene Kunden ergänzt,
da das Kapitel mit S. 177 endet.

Co-Authored-By: Claude Opus 5.5 <noreply@anthropic.com>
Claude-Session: https://claude.ai/code/session_01Jd4gkFAf9APjAnTLoxpaas
</commit_message>
<xml_diff>
--- a/lf10-kundenvielfalt/Kundenvielfalt_LF10.pptx
+++ b/lf10-kundenvielfalt/Kundenvielfalt_LF10.pptx
@@ -126,13 +126,13 @@
   <p:extLst>
     <p:ext uri="{521415D9-36F7-43E2-AB2F-B90AF26B5E84}">
       <p14:sectionLst xmlns:p14="http://schemas.microsoft.com/office/powerpoint/2010/main">
-        <p14:section name="Start" id="{1ff28e69-c2a5-467b-511f-b7d4d99976ad}">
+        <p14:section name="Start" id="{48c23ccd-9365-7036-0e95-30dc2c2e34b1}">
           <p14:sldIdLst>
             <p14:sldId id="256"/>
             <p14:sldId id="257"/>
           </p14:sldIdLst>
         </p14:section>
-        <p14:section name="Kundengruppen" id="{a86536a5-a3a5-7e6f-b91b-8c862e68c7e7}">
+        <p14:section name="Kundengruppen" id="{fafa1166-386e-067a-4e0b-30ae3c00902d}">
           <p14:sldIdLst>
             <p14:sldId id="258"/>
             <p14:sldId id="259"/>
@@ -140,7 +140,7 @@
             <p14:sldId id="261"/>
           </p14:sldIdLst>
         </p14:section>
-        <p14:section name="Altersgruppen" id="{703c06d0-b37c-a3c5-c49c-79cba26961be}">
+        <p14:section name="Altersgruppen" id="{e934f70e-8daa-c29c-c80e-1639a558f322}">
           <p14:sldIdLst>
             <p14:sldId id="262"/>
             <p14:sldId id="263"/>
@@ -149,13 +149,13 @@
             <p14:sldId id="266"/>
           </p14:sldIdLst>
         </p14:section>
-        <p14:section name="Internationale Kunden" id="{762c976f-b3fd-03d9-8ab7-8dc881cc78be}">
+        <p14:section name="Internationale Kunden" id="{3cbbf9a3-9921-4553-6cf9-9478836e0646}">
           <p14:sldIdLst>
             <p14:sldId id="267"/>
             <p14:sldId id="268"/>
           </p14:sldIdLst>
         </p14:section>
-        <p14:section name="Kundentypen" id="{9daa4045-ab2d-ab66-55d4-3ca1d5e6947a}">
+        <p14:section name="Kundentypen" id="{a3f34a7f-d64f-284c-9997-31b54e07aeb8}">
           <p14:sldIdLst>
             <p14:sldId id="269"/>
             <p14:sldId id="270"/>
@@ -165,7 +165,7 @@
             <p14:sldId id="274"/>
           </p14:sldIdLst>
         </p14:section>
-        <p14:section name="Abschluss" id="{e7c3399e-0021-7e08-3a62-d492e34c5cd3}">
+        <p14:section name="Abschluss" id="{34e6ae5a-ee07-5904-5279-9a56cde05e35}">
           <p14:sldIdLst>
             <p14:sldId id="275"/>
           </p14:sldIdLst>
@@ -10956,7 +10956,7 @@
                   <a:schemeClr val="tx1"/>
                 </a:solidFill>
               </a:rPr>
-              <a:t>Wie Sie helfen, steht im Buch auf S. 178.</a:t>
+              <a:t>Wenige Artikel vorlegen, Vor- und Nachteile klar gegenüberstellen, Empfehlung geben.</a:t>
             </a:r>
             <a:endParaRPr lang="en-US" sz="1700" dirty="0"/>
           </a:p>

</xml_diff>